<commit_message>
agent and speech related files
</commit_message>
<xml_diff>
--- a/jarvis.pptx
+++ b/jarvis.pptx
@@ -5,10 +5,10 @@
     <p:sldMasterId id="2147483648" r:id="rId1"/>
   </p:sldMasterIdLst>
   <p:notesMasterIdLst>
-    <p:notesMasterId r:id="rId12"/>
+    <p:notesMasterId r:id="rId13"/>
   </p:notesMasterIdLst>
   <p:handoutMasterIdLst>
-    <p:handoutMasterId r:id="rId13"/>
+    <p:handoutMasterId r:id="rId14"/>
   </p:handoutMasterIdLst>
   <p:sldIdLst>
     <p:sldId id="256" r:id="rId2"/>
@@ -20,7 +20,8 @@
     <p:sldId id="282" r:id="rId8"/>
     <p:sldId id="265" r:id="rId9"/>
     <p:sldId id="283" r:id="rId10"/>
-    <p:sldId id="259" r:id="rId11"/>
+    <p:sldId id="284" r:id="rId11"/>
+    <p:sldId id="259" r:id="rId12"/>
   </p:sldIdLst>
   <p:sldSz cx="12192000" cy="6858000"/>
   <p:notesSz cx="6858000" cy="9144000"/>
@@ -133,6 +134,7 @@
             <p14:sldId id="282"/>
             <p14:sldId id="265"/>
             <p14:sldId id="283"/>
+            <p14:sldId id="284"/>
             <p14:sldId id="259"/>
           </p14:sldIdLst>
         </p14:section>
@@ -239,7 +241,7 @@
           <a:p>
             <a:fld id="{316DDEA4-190E-4095-9456-293A439BF9D4}" type="datetimeFigureOut">
               <a:rPr lang="en-US" smtClean="0"/>
-              <a:t>6/21/26</a:t>
+              <a:t>10/28/26</a:t>
             </a:fld>
             <a:endParaRPr lang="en-US"/>
           </a:p>
@@ -417,7 +419,7 @@
           <a:p>
             <a:fld id="{97D3A0AD-F7F8-4E22-8D44-7E72D8F4DC21}" type="datetimeFigureOut">
               <a:rPr lang="en-US" smtClean="0"/>
-              <a:t>6/21/26</a:t>
+              <a:t>10/24/26</a:t>
             </a:fld>
             <a:endParaRPr lang="en-US"/>
           </a:p>
@@ -832,7 +834,7 @@
           <a:p>
             <a:fld id="{B4BC4C42-D1D2-48A6-888E-BB154087F9F6}" type="datetime1">
               <a:rPr lang="en-US" smtClean="0"/>
-              <a:t>6/21/26</a:t>
+              <a:t>10/24/26</a:t>
             </a:fld>
             <a:endParaRPr lang="en-US"/>
           </a:p>
@@ -1033,7 +1035,7 @@
           <a:p>
             <a:fld id="{18316AE6-2325-49DB-B148-26330E2FD277}" type="datetime1">
               <a:rPr lang="en-US" smtClean="0"/>
-              <a:t>6/21/26</a:t>
+              <a:t>10/24/26</a:t>
             </a:fld>
             <a:endParaRPr lang="en-US"/>
           </a:p>
@@ -1244,7 +1246,7 @@
           <a:p>
             <a:fld id="{6ECF08CB-49A1-43D4-9E9B-0DBBFBE54C08}" type="datetime1">
               <a:rPr lang="en-US" smtClean="0"/>
-              <a:t>6/21/26</a:t>
+              <a:t>10/24/26</a:t>
             </a:fld>
             <a:endParaRPr lang="en-US"/>
           </a:p>
@@ -1445,7 +1447,7 @@
           <a:p>
             <a:fld id="{105BBFFB-78F7-45D0-B0F7-C9ABBFCC4691}" type="datetime1">
               <a:rPr lang="en-US" smtClean="0"/>
-              <a:t>6/21/26</a:t>
+              <a:t>10/24/26</a:t>
             </a:fld>
             <a:endParaRPr lang="en-US"/>
           </a:p>
@@ -1723,7 +1725,7 @@
           <a:p>
             <a:fld id="{7277E951-9294-4411-ABD9-4F5B08EBC92B}" type="datetime1">
               <a:rPr lang="en-US" smtClean="0"/>
-              <a:t>6/21/26</a:t>
+              <a:t>10/24/26</a:t>
             </a:fld>
             <a:endParaRPr lang="en-US"/>
           </a:p>
@@ -1991,7 +1993,7 @@
           <a:p>
             <a:fld id="{E28634BB-C7C5-4027-9EC9-E3EB86FCAEF3}" type="datetime1">
               <a:rPr lang="en-US" smtClean="0"/>
-              <a:t>6/21/26</a:t>
+              <a:t>10/24/26</a:t>
             </a:fld>
             <a:endParaRPr lang="en-US"/>
           </a:p>
@@ -2406,7 +2408,7 @@
           <a:p>
             <a:fld id="{640DA9FB-1B58-4ED0-93BA-D955084D1D32}" type="datetime1">
               <a:rPr lang="en-US" smtClean="0"/>
-              <a:t>6/21/26</a:t>
+              <a:t>10/24/26</a:t>
             </a:fld>
             <a:endParaRPr lang="en-US"/>
           </a:p>
@@ -2550,7 +2552,7 @@
           <a:p>
             <a:fld id="{5271C941-E01D-4E80-8E0E-12B6D345AD24}" type="datetime1">
               <a:rPr lang="en-US" smtClean="0"/>
-              <a:t>6/21/26</a:t>
+              <a:t>10/24/26</a:t>
             </a:fld>
             <a:endParaRPr lang="en-US"/>
           </a:p>
@@ -2666,7 +2668,7 @@
           <a:p>
             <a:fld id="{4F0F3D3D-20C8-4D64-A483-2C4C8EBC1BD9}" type="datetime1">
               <a:rPr lang="en-US" smtClean="0"/>
-              <a:t>6/21/26</a:t>
+              <a:t>10/24/26</a:t>
             </a:fld>
             <a:endParaRPr lang="en-US"/>
           </a:p>
@@ -2980,7 +2982,7 @@
           <a:p>
             <a:fld id="{3F4FD0B4-F151-47BF-95A6-DA20B44AE473}" type="datetime1">
               <a:rPr lang="en-US" smtClean="0"/>
-              <a:t>6/21/26</a:t>
+              <a:t>10/24/26</a:t>
             </a:fld>
             <a:endParaRPr lang="en-US"/>
           </a:p>
@@ -3271,7 +3273,7 @@
           <a:p>
             <a:fld id="{4B55E73E-FC96-4445-9331-78F7215BD613}" type="datetime1">
               <a:rPr lang="en-US" smtClean="0"/>
-              <a:t>6/21/26</a:t>
+              <a:t>10/24/26</a:t>
             </a:fld>
             <a:endParaRPr lang="en-US"/>
           </a:p>
@@ -3515,7 +3517,7 @@
           <a:p>
             <a:fld id="{46644D5E-C3C0-4BE1-A478-33544A5F7BFF}" type="datetime1">
               <a:rPr lang="en-US" smtClean="0"/>
-              <a:t>6/21/26</a:t>
+              <a:t>10/24/26</a:t>
             </a:fld>
             <a:endParaRPr lang="en-US"/>
           </a:p>
@@ -4072,114 +4074,6 @@
 <file path=ppt/slides/slide10.xml><?xml version="1.0" encoding="utf-8"?>
 <p:sld xmlns:a="http://schemas.openxmlformats.org/drawingml/2006/main" xmlns:r="http://schemas.openxmlformats.org/officeDocument/2006/relationships" xmlns:p="http://schemas.openxmlformats.org/presentationml/2006/main">
   <p:cSld>
-    <p:spTree>
-      <p:nvGrpSpPr>
-        <p:cNvPr id="1" name=""/>
-        <p:cNvGrpSpPr/>
-        <p:nvPr/>
-      </p:nvGrpSpPr>
-      <p:grpSpPr>
-        <a:xfrm>
-          <a:off x="0" y="0"/>
-          <a:ext cx="0" cy="0"/>
-          <a:chOff x="0" y="0"/>
-          <a:chExt cx="0" cy="0"/>
-        </a:xfrm>
-      </p:grpSpPr>
-      <p:pic>
-        <p:nvPicPr>
-          <p:cNvPr id="5" name="Picture 4" descr="A white background with hexagons&#10;&#10;Description automatically generated">
-            <a:extLst>
-              <a:ext uri="{FF2B5EF4-FFF2-40B4-BE49-F238E27FC236}">
-                <a16:creationId xmlns:a16="http://schemas.microsoft.com/office/drawing/2014/main" id="{57167341-08E4-3FAE-09CA-8A71930D4A9E}"/>
-              </a:ext>
-            </a:extLst>
-          </p:cNvPr>
-          <p:cNvPicPr>
-            <a:picLocks noChangeAspect="1"/>
-          </p:cNvPicPr>
-          <p:nvPr/>
-        </p:nvPicPr>
-        <p:blipFill>
-          <a:blip r:embed="rId2">
-            <a:extLst>
-              <a:ext uri="{28A0092B-C50C-407E-A947-70E740481C1C}">
-                <a14:useLocalDpi xmlns:a14="http://schemas.microsoft.com/office/drawing/2010/main" val="0"/>
-              </a:ext>
-            </a:extLst>
-          </a:blip>
-          <a:stretch>
-            <a:fillRect/>
-          </a:stretch>
-        </p:blipFill>
-        <p:spPr>
-          <a:xfrm>
-            <a:off x="-1" y="1"/>
-            <a:ext cx="12192001" cy="6857612"/>
-          </a:xfrm>
-          <a:prstGeom prst="rect">
-            <a:avLst/>
-          </a:prstGeom>
-        </p:spPr>
-      </p:pic>
-      <p:sp>
-        <p:nvSpPr>
-          <p:cNvPr id="2" name="TextBox 1">
-            <a:extLst>
-              <a:ext uri="{FF2B5EF4-FFF2-40B4-BE49-F238E27FC236}">
-                <a16:creationId xmlns:a16="http://schemas.microsoft.com/office/drawing/2014/main" id="{AF1FBD9A-BC88-48B5-137F-AC54A2E234E0}"/>
-              </a:ext>
-            </a:extLst>
-          </p:cNvPr>
-          <p:cNvSpPr txBox="1"/>
-          <p:nvPr/>
-        </p:nvSpPr>
-        <p:spPr>
-          <a:xfrm>
-            <a:off x="1542473" y="2844800"/>
-            <a:ext cx="9596582" cy="769441"/>
-          </a:xfrm>
-          <a:prstGeom prst="rect">
-            <a:avLst/>
-          </a:prstGeom>
-          <a:noFill/>
-        </p:spPr>
-        <p:txBody>
-          <a:bodyPr wrap="square" rtlCol="0">
-            <a:spAutoFit/>
-          </a:bodyPr>
-          <a:lstStyle/>
-          <a:p>
-            <a:pPr algn="ctr"/>
-            <a:r>
-              <a:rPr lang="en-US" sz="4400" dirty="0">
-                <a:solidFill>
-                  <a:srgbClr val="002060"/>
-                </a:solidFill>
-                <a:latin typeface="Roboto Light" panose="02000000000000000000" pitchFamily="2" charset="0"/>
-                <a:ea typeface="Roboto Light" panose="02000000000000000000" pitchFamily="2" charset="0"/>
-              </a:rPr>
-              <a:t>Questions?</a:t>
-            </a:r>
-          </a:p>
-        </p:txBody>
-      </p:sp>
-    </p:spTree>
-    <p:extLst>
-      <p:ext uri="{BB962C8B-B14F-4D97-AF65-F5344CB8AC3E}">
-        <p14:creationId xmlns:p14="http://schemas.microsoft.com/office/powerpoint/2010/main" val="589305988"/>
-      </p:ext>
-    </p:extLst>
-  </p:cSld>
-  <p:clrMapOvr>
-    <a:masterClrMapping/>
-  </p:clrMapOvr>
-</p:sld>
-</file>
-
-<file path=ppt/slides/slide2.xml><?xml version="1.0" encoding="utf-8"?>
-<p:sld xmlns:a="http://schemas.openxmlformats.org/drawingml/2006/main" xmlns:r="http://schemas.openxmlformats.org/officeDocument/2006/relationships" xmlns:p="http://schemas.openxmlformats.org/presentationml/2006/main">
-  <p:cSld>
     <p:bg>
       <p:bgPr>
         <a:solidFill>
@@ -4190,7 +4084,13 @@
     </p:bg>
     <p:spTree>
       <p:nvGrpSpPr>
-        <p:cNvPr id="1" name=""/>
+        <p:cNvPr id="1" name="">
+          <a:extLst>
+            <a:ext uri="{FF2B5EF4-FFF2-40B4-BE49-F238E27FC236}">
+              <a16:creationId xmlns:a16="http://schemas.microsoft.com/office/drawing/2014/main" id="{4EDB7EFC-D8C0-39B5-CAAB-94D085C5A8EB}"/>
+            </a:ext>
+          </a:extLst>
+        </p:cNvPr>
         <p:cNvGrpSpPr/>
         <p:nvPr/>
       </p:nvGrpSpPr>
@@ -4207,7 +4107,7 @@
           <p:cNvPr id="12" name="Picture 11">
             <a:extLst>
               <a:ext uri="{FF2B5EF4-FFF2-40B4-BE49-F238E27FC236}">
-                <a16:creationId xmlns:a16="http://schemas.microsoft.com/office/drawing/2014/main" id="{E5715E08-146D-0759-2720-E84D70786BC1}"/>
+                <a16:creationId xmlns:a16="http://schemas.microsoft.com/office/drawing/2014/main" id="{2FF33F32-1764-0BC6-5467-6818A065C199}"/>
               </a:ext>
             </a:extLst>
           </p:cNvPr>
@@ -4224,8 +4124,8 @@
         </p:blipFill>
         <p:spPr>
           <a:xfrm>
-            <a:off x="-11151" y="0"/>
-            <a:ext cx="12188952" cy="6858000"/>
+            <a:off x="1" y="612"/>
+            <a:ext cx="12188952" cy="6864271"/>
           </a:xfrm>
           <a:prstGeom prst="rect">
             <a:avLst/>
@@ -4237,7 +4137,7 @@
           <p:cNvPr id="10" name="Rectangle 9">
             <a:extLst>
               <a:ext uri="{FF2B5EF4-FFF2-40B4-BE49-F238E27FC236}">
-                <a16:creationId xmlns:a16="http://schemas.microsoft.com/office/drawing/2014/main" id="{42A4FC2C-047E-45A5-965D-8E1E3BF09BC6}"/>
+                <a16:creationId xmlns:a16="http://schemas.microsoft.com/office/drawing/2014/main" id="{7964CDEF-1306-B5AB-FDC2-AE485A74FA61}"/>
               </a:ext>
               <a:ext uri="{C183D7F6-B498-43B3-948B-1728B52AA6E4}">
                 <adec:decorative xmlns:adec="http://schemas.microsoft.com/office/drawing/2017/decorative" val="1"/>
@@ -4392,7 +4292,7 @@
           <p:cNvPr id="2" name="Freeform: Shape 1">
             <a:extLst>
               <a:ext uri="{FF2B5EF4-FFF2-40B4-BE49-F238E27FC236}">
-                <a16:creationId xmlns:a16="http://schemas.microsoft.com/office/drawing/2014/main" id="{6DAD8027-1835-30F1-2138-FEEFB4294F47}"/>
+                <a16:creationId xmlns:a16="http://schemas.microsoft.com/office/drawing/2014/main" id="{E107C72B-661C-E66D-1494-4D367A0DD89C}"/>
               </a:ext>
             </a:extLst>
           </p:cNvPr>
@@ -4510,7 +4410,7 @@
           <p:cNvPr id="4" name="TextBox 3">
             <a:extLst>
               <a:ext uri="{FF2B5EF4-FFF2-40B4-BE49-F238E27FC236}">
-                <a16:creationId xmlns:a16="http://schemas.microsoft.com/office/drawing/2014/main" id="{9E3EEE10-82D5-87E4-5878-1CDBB4D30E23}"/>
+                <a16:creationId xmlns:a16="http://schemas.microsoft.com/office/drawing/2014/main" id="{74E3A58E-C6B5-7785-0860-D58C1ED742BF}"/>
               </a:ext>
             </a:extLst>
           </p:cNvPr>
@@ -4519,8 +4419,8 @@
         </p:nvSpPr>
         <p:spPr>
           <a:xfrm>
-            <a:off x="566057" y="572220"/>
-            <a:ext cx="3302558" cy="523220"/>
+            <a:off x="0" y="396607"/>
+            <a:ext cx="14954491" cy="2677656"/>
           </a:xfrm>
           <a:prstGeom prst="rect">
             <a:avLst/>
@@ -4533,163 +4433,76 @@
           </a:bodyPr>
           <a:lstStyle/>
           <a:p>
-            <a:r>
-              <a:rPr lang="en-US" sz="2800" dirty="0"/>
-              <a:t>Who is Monte Chan?</a:t>
-            </a:r>
-          </a:p>
-        </p:txBody>
-      </p:sp>
-      <p:sp>
-        <p:nvSpPr>
-          <p:cNvPr id="5" name="TextBox 4">
-            <a:extLst>
-              <a:ext uri="{FF2B5EF4-FFF2-40B4-BE49-F238E27FC236}">
-                <a16:creationId xmlns:a16="http://schemas.microsoft.com/office/drawing/2014/main" id="{EF36D861-DF68-5C6D-8119-18A5814B2A68}"/>
-              </a:ext>
-            </a:extLst>
-          </p:cNvPr>
-          <p:cNvSpPr txBox="1"/>
-          <p:nvPr/>
-        </p:nvSpPr>
-        <p:spPr>
-          <a:xfrm>
-            <a:off x="675249" y="1567027"/>
-            <a:ext cx="11015003" cy="3785652"/>
-          </a:xfrm>
-          <a:prstGeom prst="rect">
-            <a:avLst/>
-          </a:prstGeom>
-          <a:noFill/>
-        </p:spPr>
-        <p:txBody>
-          <a:bodyPr wrap="square" rtlCol="0">
-            <a:spAutoFit/>
-          </a:bodyPr>
-          <a:lstStyle/>
-          <a:p>
-            <a:pPr marL="285750" indent="-285750">
+            <a:pPr marL="514350" indent="-514350">
               <a:buFont typeface="Arial" panose="020B0604020202020204" pitchFamily="34" charset="0"/>
               <a:buChar char="•"/>
             </a:pPr>
             <a:r>
-              <a:rPr lang="en-US" sz="2400" dirty="0"/>
-              <a:t>Senior ColdFusion Developer at Shoes For Crews</a:t>
-            </a:r>
-          </a:p>
-          <a:p>
-            <a:pPr marL="285750" indent="-285750">
+              <a:rPr lang="en-US" sz="2800" dirty="0"/>
+              <a:t>JavaScript – simplest way</a:t>
+            </a:r>
+          </a:p>
+          <a:p>
+            <a:pPr marL="514350" indent="-514350">
               <a:buFont typeface="Arial" panose="020B0604020202020204" pitchFamily="34" charset="0"/>
               <a:buChar char="•"/>
             </a:pPr>
             <a:r>
-              <a:rPr lang="en-US" sz="2400" dirty="0"/>
-              <a:t>Has used ColdFusion since version 4.5 back in 1999</a:t>
-            </a:r>
-          </a:p>
-          <a:p>
-            <a:pPr marL="285750" indent="-285750">
+              <a:rPr lang="en-US" sz="2800" dirty="0"/>
+              <a:t>Web Speech API – No need to include external libraries</a:t>
+            </a:r>
+          </a:p>
+          <a:p>
+            <a:pPr marL="514350" indent="-514350">
               <a:buFont typeface="Arial" panose="020B0604020202020204" pitchFamily="34" charset="0"/>
               <a:buChar char="•"/>
             </a:pPr>
             <a:r>
-              <a:rPr lang="en-US" sz="2400" dirty="0"/>
-              <a:t>Has developed web applications which were used in different industries (ex. Health insurance, education, </a:t>
-            </a:r>
-            <a:r>
-              <a:rPr lang="en-US" sz="2400" dirty="0" err="1"/>
-              <a:t>finTech</a:t>
-            </a:r>
-            <a:r>
-              <a:rPr lang="en-US" sz="2400" dirty="0"/>
-              <a:t>, e-commerce…etc.) </a:t>
-            </a:r>
-          </a:p>
-          <a:p>
-            <a:pPr marL="285750" indent="-285750">
+              <a:rPr lang="en-US" sz="2800" dirty="0">
+                <a:hlinkClick r:id="rId3"/>
+              </a:rPr>
+              <a:t>https://developer.mozilla.org/en-US/docs/Web/API/Web_Speech_API</a:t>
+            </a:r>
+            <a:endParaRPr lang="en-US" sz="2800" dirty="0"/>
+          </a:p>
+          <a:p>
+            <a:pPr marL="971550" lvl="1" indent="-514350">
               <a:buFont typeface="Arial" panose="020B0604020202020204" pitchFamily="34" charset="0"/>
               <a:buChar char="•"/>
             </a:pPr>
             <a:r>
-              <a:rPr lang="en-US" sz="2400" dirty="0"/>
-              <a:t>Was one of the co-managers of Alamo ColdFusion User Group</a:t>
-            </a:r>
-          </a:p>
-          <a:p>
-            <a:pPr marL="285750" indent="-285750">
+              <a:rPr lang="en-US" sz="2800" dirty="0" err="1"/>
+              <a:t>SpeechRecognition</a:t>
+            </a:r>
+            <a:r>
+              <a:rPr lang="en-US" sz="2800" dirty="0"/>
+              <a:t> – Speech to Text</a:t>
+            </a:r>
+          </a:p>
+          <a:p>
+            <a:pPr marL="971550" lvl="1" indent="-514350">
               <a:buFont typeface="Arial" panose="020B0604020202020204" pitchFamily="34" charset="0"/>
               <a:buChar char="•"/>
             </a:pPr>
             <a:r>
-              <a:rPr lang="en-US" sz="2400" dirty="0"/>
-              <a:t>Has a </a:t>
-            </a:r>
-            <a:r>
-              <a:rPr lang="en-US" sz="2400" dirty="0" err="1"/>
-              <a:t>youTube</a:t>
-            </a:r>
-            <a:r>
-              <a:rPr lang="en-US" sz="2400" dirty="0"/>
-              <a:t> channel, Geek Talk. </a:t>
-            </a:r>
-            <a:r>
-              <a:rPr lang="en-US" sz="2400" dirty="0">
-                <a:hlinkClick r:id="rId3"/>
-              </a:rPr>
-              <a:t>https://www.youtube.com/@geektalk2004</a:t>
-            </a:r>
-            <a:endParaRPr lang="en-US" sz="2400" dirty="0"/>
-          </a:p>
-          <a:p>
-            <a:pPr marL="285750" indent="-285750">
-              <a:buFont typeface="Arial" panose="020B0604020202020204" pitchFamily="34" charset="0"/>
-              <a:buChar char="•"/>
-            </a:pPr>
-            <a:r>
-              <a:rPr lang="en-US" sz="2400" dirty="0"/>
-              <a:t>On different social media platforms but mostly on Facebook.  You can find me on Facebook at https://</a:t>
-            </a:r>
-            <a:r>
-              <a:rPr lang="en-US" sz="2400" dirty="0" err="1"/>
-              <a:t>www.facebook.com</a:t>
-            </a:r>
-            <a:r>
-              <a:rPr lang="en-US" sz="2400" dirty="0"/>
-              <a:t>/</a:t>
-            </a:r>
-            <a:r>
-              <a:rPr lang="en-US" sz="2400" dirty="0" err="1"/>
-              <a:t>monte.chan</a:t>
-            </a:r>
-            <a:r>
-              <a:rPr lang="en-US" sz="2400" dirty="0"/>
-              <a:t>/</a:t>
-            </a:r>
-          </a:p>
-          <a:p>
-            <a:pPr marL="285750" indent="-285750">
-              <a:buFont typeface="Arial" panose="020B0604020202020204" pitchFamily="34" charset="0"/>
-              <a:buChar char="•"/>
-            </a:pPr>
-            <a:r>
-              <a:rPr lang="en-US" sz="2400" dirty="0"/>
-              <a:t>You can email me at </a:t>
-            </a:r>
-            <a:r>
-              <a:rPr lang="en-US" sz="2400" dirty="0" err="1"/>
-              <a:t>monte@monteandjanicechan.com</a:t>
-            </a:r>
-            <a:r>
-              <a:rPr lang="en-US" sz="2400" dirty="0"/>
-              <a:t> but you may get a quicker response if you send me a message in Facebook Messenger.</a:t>
-            </a:r>
+              <a:rPr lang="en-US" sz="2800" dirty="0" err="1"/>
+              <a:t>SpeechSynthesisUtterance</a:t>
+            </a:r>
+            <a:r>
+              <a:rPr lang="en-US" sz="2800" dirty="0"/>
+              <a:t> – Text to Speech</a:t>
+            </a:r>
+          </a:p>
+          <a:p>
+            <a:pPr lvl="1"/>
+            <a:endParaRPr lang="en-US" sz="2800" dirty="0"/>
           </a:p>
         </p:txBody>
       </p:sp>
     </p:spTree>
     <p:extLst>
       <p:ext uri="{BB962C8B-B14F-4D97-AF65-F5344CB8AC3E}">
-        <p14:creationId xmlns:p14="http://schemas.microsoft.com/office/powerpoint/2010/main" val="2885452000"/>
+        <p14:creationId xmlns:p14="http://schemas.microsoft.com/office/powerpoint/2010/main" val="452538529"/>
       </p:ext>
     </p:extLst>
   </p:cSld>
@@ -4699,7 +4512,115 @@
 </p:sld>
 </file>
 
-<file path=ppt/slides/slide3.xml><?xml version="1.0" encoding="utf-8"?>
+<file path=ppt/slides/slide11.xml><?xml version="1.0" encoding="utf-8"?>
+<p:sld xmlns:a="http://schemas.openxmlformats.org/drawingml/2006/main" xmlns:r="http://schemas.openxmlformats.org/officeDocument/2006/relationships" xmlns:p="http://schemas.openxmlformats.org/presentationml/2006/main">
+  <p:cSld>
+    <p:spTree>
+      <p:nvGrpSpPr>
+        <p:cNvPr id="1" name=""/>
+        <p:cNvGrpSpPr/>
+        <p:nvPr/>
+      </p:nvGrpSpPr>
+      <p:grpSpPr>
+        <a:xfrm>
+          <a:off x="0" y="0"/>
+          <a:ext cx="0" cy="0"/>
+          <a:chOff x="0" y="0"/>
+          <a:chExt cx="0" cy="0"/>
+        </a:xfrm>
+      </p:grpSpPr>
+      <p:pic>
+        <p:nvPicPr>
+          <p:cNvPr id="5" name="Picture 4" descr="A white background with hexagons&#10;&#10;Description automatically generated">
+            <a:extLst>
+              <a:ext uri="{FF2B5EF4-FFF2-40B4-BE49-F238E27FC236}">
+                <a16:creationId xmlns:a16="http://schemas.microsoft.com/office/drawing/2014/main" id="{57167341-08E4-3FAE-09CA-8A71930D4A9E}"/>
+              </a:ext>
+            </a:extLst>
+          </p:cNvPr>
+          <p:cNvPicPr>
+            <a:picLocks noChangeAspect="1"/>
+          </p:cNvPicPr>
+          <p:nvPr/>
+        </p:nvPicPr>
+        <p:blipFill>
+          <a:blip r:embed="rId2">
+            <a:extLst>
+              <a:ext uri="{28A0092B-C50C-407E-A947-70E740481C1C}">
+                <a14:useLocalDpi xmlns:a14="http://schemas.microsoft.com/office/drawing/2010/main" val="0"/>
+              </a:ext>
+            </a:extLst>
+          </a:blip>
+          <a:stretch>
+            <a:fillRect/>
+          </a:stretch>
+        </p:blipFill>
+        <p:spPr>
+          <a:xfrm>
+            <a:off x="-1" y="1"/>
+            <a:ext cx="12192001" cy="6857612"/>
+          </a:xfrm>
+          <a:prstGeom prst="rect">
+            <a:avLst/>
+          </a:prstGeom>
+        </p:spPr>
+      </p:pic>
+      <p:sp>
+        <p:nvSpPr>
+          <p:cNvPr id="2" name="TextBox 1">
+            <a:extLst>
+              <a:ext uri="{FF2B5EF4-FFF2-40B4-BE49-F238E27FC236}">
+                <a16:creationId xmlns:a16="http://schemas.microsoft.com/office/drawing/2014/main" id="{AF1FBD9A-BC88-48B5-137F-AC54A2E234E0}"/>
+              </a:ext>
+            </a:extLst>
+          </p:cNvPr>
+          <p:cNvSpPr txBox="1"/>
+          <p:nvPr/>
+        </p:nvSpPr>
+        <p:spPr>
+          <a:xfrm>
+            <a:off x="1542473" y="2844800"/>
+            <a:ext cx="9596582" cy="769441"/>
+          </a:xfrm>
+          <a:prstGeom prst="rect">
+            <a:avLst/>
+          </a:prstGeom>
+          <a:noFill/>
+        </p:spPr>
+        <p:txBody>
+          <a:bodyPr wrap="square" rtlCol="0">
+            <a:spAutoFit/>
+          </a:bodyPr>
+          <a:lstStyle/>
+          <a:p>
+            <a:pPr algn="ctr"/>
+            <a:r>
+              <a:rPr lang="en-US" sz="4400" dirty="0">
+                <a:solidFill>
+                  <a:srgbClr val="002060"/>
+                </a:solidFill>
+                <a:latin typeface="Roboto Light" panose="02000000000000000000" pitchFamily="2" charset="0"/>
+                <a:ea typeface="Roboto Light" panose="02000000000000000000" pitchFamily="2" charset="0"/>
+              </a:rPr>
+              <a:t>Questions?</a:t>
+            </a:r>
+          </a:p>
+        </p:txBody>
+      </p:sp>
+    </p:spTree>
+    <p:extLst>
+      <p:ext uri="{BB962C8B-B14F-4D97-AF65-F5344CB8AC3E}">
+        <p14:creationId xmlns:p14="http://schemas.microsoft.com/office/powerpoint/2010/main" val="589305988"/>
+      </p:ext>
+    </p:extLst>
+  </p:cSld>
+  <p:clrMapOvr>
+    <a:masterClrMapping/>
+  </p:clrMapOvr>
+</p:sld>
+</file>
+
+<file path=ppt/slides/slide2.xml><?xml version="1.0" encoding="utf-8"?>
 <p:sld xmlns:a="http://schemas.openxmlformats.org/drawingml/2006/main" xmlns:r="http://schemas.openxmlformats.org/officeDocument/2006/relationships" xmlns:p="http://schemas.openxmlformats.org/presentationml/2006/main">
   <p:cSld>
     <p:bg>
@@ -4906,41 +4827,6 @@
           <a:p>
             <a:pPr algn="ctr"/>
             <a:endParaRPr lang="en-US"/>
-          </a:p>
-        </p:txBody>
-      </p:sp>
-      <p:sp>
-        <p:nvSpPr>
-          <p:cNvPr id="11" name="Footer Placeholder 10">
-            <a:extLst>
-              <a:ext uri="{FF2B5EF4-FFF2-40B4-BE49-F238E27FC236}">
-                <a16:creationId xmlns:a16="http://schemas.microsoft.com/office/drawing/2014/main" id="{BB1C0603-8047-1EA8-656C-93CC9FF56BB4}"/>
-              </a:ext>
-            </a:extLst>
-          </p:cNvPr>
-          <p:cNvSpPr>
-            <a:spLocks noGrp="1"/>
-          </p:cNvSpPr>
-          <p:nvPr>
-            <p:ph type="ftr" sz="quarter" idx="11"/>
-          </p:nvPr>
-        </p:nvSpPr>
-        <p:spPr>
-          <a:xfrm>
-            <a:off x="8696325" y="6462298"/>
-            <a:ext cx="4114800" cy="365125"/>
-          </a:xfrm>
-        </p:spPr>
-        <p:txBody>
-          <a:bodyPr/>
-          <a:lstStyle/>
-          <a:p>
-            <a:r>
-              <a:rPr lang="en-US" sz="1400" dirty="0">
-                <a:latin typeface="DunbarTall" panose="00000000000000020000" pitchFamily="50" charset="0"/>
-              </a:rPr>
-              <a:t>	 </a:t>
-            </a:r>
           </a:p>
         </p:txBody>
       </p:sp>
@@ -5092,7 +4978,7 @@
           <a:p>
             <a:r>
               <a:rPr lang="en-US" sz="2800" dirty="0"/>
-              <a:t>Before we begin…</a:t>
+              <a:t>Who is Monte Chan?</a:t>
             </a:r>
           </a:p>
         </p:txBody>
@@ -5112,7 +4998,7 @@
         <p:spPr>
           <a:xfrm>
             <a:off x="675249" y="1567027"/>
-            <a:ext cx="11015003" cy="2677656"/>
+            <a:ext cx="11015003" cy="3785652"/>
           </a:xfrm>
           <a:prstGeom prst="rect">
             <a:avLst/>
@@ -5131,23 +5017,8 @@
             </a:pPr>
             <a:r>
               <a:rPr lang="en-US" sz="2400" dirty="0"/>
-              <a:t>The presentation slides will be uploaded to my </a:t>
-            </a:r>
-            <a:r>
-              <a:rPr lang="en-US" sz="2400" dirty="0" err="1"/>
-              <a:t>Github</a:t>
-            </a:r>
-            <a:r>
-              <a:rPr lang="en-US" sz="2400" dirty="0"/>
-              <a:t> account at </a:t>
-            </a:r>
-            <a:r>
-              <a:rPr lang="en-US" sz="2400" dirty="0">
-                <a:hlinkClick r:id="rId3"/>
-              </a:rPr>
-              <a:t>https://github.com/knittingguy</a:t>
-            </a:r>
-            <a:endParaRPr lang="en-US" sz="2400" dirty="0"/>
+              <a:t>Senior ColdFusion Developer at Shoes For Crews</a:t>
+            </a:r>
           </a:p>
           <a:p>
             <a:pPr marL="285750" indent="-285750">
@@ -5156,23 +5027,7 @@
             </a:pPr>
             <a:r>
               <a:rPr lang="en-US" sz="2400" dirty="0"/>
-              <a:t>Inspiration:  </a:t>
-            </a:r>
-            <a:r>
-              <a:rPr lang="en-US" sz="2400" dirty="0" err="1"/>
-              <a:t>Github</a:t>
-            </a:r>
-            <a:r>
-              <a:rPr lang="en-US" sz="2400" dirty="0"/>
-              <a:t> </a:t>
-            </a:r>
-            <a:r>
-              <a:rPr lang="en-US" sz="2400" dirty="0" err="1"/>
-              <a:t>CodeQL</a:t>
-            </a:r>
-            <a:r>
-              <a:rPr lang="en-US" sz="2400" dirty="0"/>
-              <a:t> – semantic search on your codebase.  Treating your codebase as data.  Combining the AI chat capabilities with your codebase.  Essentially, it is a poor man version of J.A.R.V.I.S. on your codebase.  </a:t>
+              <a:t>Has used ColdFusion since version 4.5 back in 1999</a:t>
             </a:r>
           </a:p>
           <a:p>
@@ -5182,18 +5037,102 @@
             </a:pPr>
             <a:r>
               <a:rPr lang="en-US" sz="2400" dirty="0"/>
-              <a:t>“With great power comes … great self-indulgence.” --- Ben Nadel</a:t>
-            </a:r>
-          </a:p>
-          <a:p>
+              <a:t>Has developed web applications which were used in different industries (ex. Health insurance, education, </a:t>
+            </a:r>
+            <a:r>
+              <a:rPr lang="en-US" sz="2400" dirty="0" err="1"/>
+              <a:t>finTech</a:t>
+            </a:r>
+            <a:r>
+              <a:rPr lang="en-US" sz="2400" dirty="0"/>
+              <a:t>, e-commerce…etc.) </a:t>
+            </a:r>
+          </a:p>
+          <a:p>
+            <a:pPr marL="285750" indent="-285750">
+              <a:buFont typeface="Arial" panose="020B0604020202020204" pitchFamily="34" charset="0"/>
+              <a:buChar char="•"/>
+            </a:pPr>
+            <a:r>
+              <a:rPr lang="en-US" sz="2400" dirty="0"/>
+              <a:t>Was one of the co-managers of Alamo ColdFusion User Group</a:t>
+            </a:r>
+          </a:p>
+          <a:p>
+            <a:pPr marL="285750" indent="-285750">
+              <a:buFont typeface="Arial" panose="020B0604020202020204" pitchFamily="34" charset="0"/>
+              <a:buChar char="•"/>
+            </a:pPr>
+            <a:r>
+              <a:rPr lang="en-US" sz="2400" dirty="0"/>
+              <a:t>Has a </a:t>
+            </a:r>
+            <a:r>
+              <a:rPr lang="en-US" sz="2400" dirty="0" err="1"/>
+              <a:t>youTube</a:t>
+            </a:r>
+            <a:r>
+              <a:rPr lang="en-US" sz="2400" dirty="0"/>
+              <a:t> channel, Geek Talk. </a:t>
+            </a:r>
+            <a:r>
+              <a:rPr lang="en-US" sz="2400" dirty="0">
+                <a:hlinkClick r:id="rId3"/>
+              </a:rPr>
+              <a:t>https://www.youtube.com/@geektalk2004</a:t>
+            </a:r>
             <a:endParaRPr lang="en-US" sz="2400" dirty="0"/>
+          </a:p>
+          <a:p>
+            <a:pPr marL="285750" indent="-285750">
+              <a:buFont typeface="Arial" panose="020B0604020202020204" pitchFamily="34" charset="0"/>
+              <a:buChar char="•"/>
+            </a:pPr>
+            <a:r>
+              <a:rPr lang="en-US" sz="2400" dirty="0"/>
+              <a:t>On different social media platforms but mostly on Facebook.  You can find me on Facebook at https://</a:t>
+            </a:r>
+            <a:r>
+              <a:rPr lang="en-US" sz="2400" dirty="0" err="1"/>
+              <a:t>www.facebook.com</a:t>
+            </a:r>
+            <a:r>
+              <a:rPr lang="en-US" sz="2400" dirty="0"/>
+              <a:t>/</a:t>
+            </a:r>
+            <a:r>
+              <a:rPr lang="en-US" sz="2400" dirty="0" err="1"/>
+              <a:t>monte.chan</a:t>
+            </a:r>
+            <a:r>
+              <a:rPr lang="en-US" sz="2400" dirty="0"/>
+              <a:t>/</a:t>
+            </a:r>
+          </a:p>
+          <a:p>
+            <a:pPr marL="285750" indent="-285750">
+              <a:buFont typeface="Arial" panose="020B0604020202020204" pitchFamily="34" charset="0"/>
+              <a:buChar char="•"/>
+            </a:pPr>
+            <a:r>
+              <a:rPr lang="en-US" sz="2400" dirty="0"/>
+              <a:t>You can email me at </a:t>
+            </a:r>
+            <a:r>
+              <a:rPr lang="en-US" sz="2400" dirty="0" err="1"/>
+              <a:t>monte@monteandjanicechan.com</a:t>
+            </a:r>
+            <a:r>
+              <a:rPr lang="en-US" sz="2400" dirty="0"/>
+              <a:t> but you may get a quicker response if you send me a message in Facebook Messenger.</a:t>
+            </a:r>
           </a:p>
         </p:txBody>
       </p:sp>
     </p:spTree>
     <p:extLst>
       <p:ext uri="{BB962C8B-B14F-4D97-AF65-F5344CB8AC3E}">
-        <p14:creationId xmlns:p14="http://schemas.microsoft.com/office/powerpoint/2010/main" val="3212058639"/>
+        <p14:creationId xmlns:p14="http://schemas.microsoft.com/office/powerpoint/2010/main" val="2885452000"/>
       </p:ext>
     </p:extLst>
   </p:cSld>
@@ -5203,7 +5142,7 @@
 </p:sld>
 </file>
 
-<file path=ppt/slides/slide4.xml><?xml version="1.0" encoding="utf-8"?>
+<file path=ppt/slides/slide3.xml><?xml version="1.0" encoding="utf-8"?>
 <p:sld xmlns:a="http://schemas.openxmlformats.org/drawingml/2006/main" xmlns:r="http://schemas.openxmlformats.org/officeDocument/2006/relationships" xmlns:p="http://schemas.openxmlformats.org/presentationml/2006/main">
   <p:cSld>
     <p:bg>
@@ -5216,13 +5155,7 @@
     </p:bg>
     <p:spTree>
       <p:nvGrpSpPr>
-        <p:cNvPr id="1" name="">
-          <a:extLst>
-            <a:ext uri="{FF2B5EF4-FFF2-40B4-BE49-F238E27FC236}">
-              <a16:creationId xmlns:a16="http://schemas.microsoft.com/office/drawing/2014/main" id="{0530EB7F-C55B-6176-476A-12CF24B64E17}"/>
-            </a:ext>
-          </a:extLst>
-        </p:cNvPr>
+        <p:cNvPr id="1" name=""/>
         <p:cNvGrpSpPr/>
         <p:nvPr/>
       </p:nvGrpSpPr>
@@ -5239,7 +5172,7 @@
           <p:cNvPr id="12" name="Picture 11">
             <a:extLst>
               <a:ext uri="{FF2B5EF4-FFF2-40B4-BE49-F238E27FC236}">
-                <a16:creationId xmlns:a16="http://schemas.microsoft.com/office/drawing/2014/main" id="{56A4C503-754C-F836-01FF-8441F9802EC0}"/>
+                <a16:creationId xmlns:a16="http://schemas.microsoft.com/office/drawing/2014/main" id="{E5715E08-146D-0759-2720-E84D70786BC1}"/>
               </a:ext>
             </a:extLst>
           </p:cNvPr>
@@ -5256,8 +5189,8 @@
         </p:blipFill>
         <p:spPr>
           <a:xfrm>
-            <a:off x="-11151" y="-6271"/>
-            <a:ext cx="12188952" cy="6864271"/>
+            <a:off x="-11151" y="0"/>
+            <a:ext cx="12188952" cy="6858000"/>
           </a:xfrm>
           <a:prstGeom prst="rect">
             <a:avLst/>
@@ -5269,7 +5202,7 @@
           <p:cNvPr id="10" name="Rectangle 9">
             <a:extLst>
               <a:ext uri="{FF2B5EF4-FFF2-40B4-BE49-F238E27FC236}">
-                <a16:creationId xmlns:a16="http://schemas.microsoft.com/office/drawing/2014/main" id="{CFE8CFDD-9079-B347-F4CB-9B6B0348403D}"/>
+                <a16:creationId xmlns:a16="http://schemas.microsoft.com/office/drawing/2014/main" id="{42A4FC2C-047E-45A5-965D-8E1E3BF09BC6}"/>
               </a:ext>
               <a:ext uri="{C183D7F6-B498-43B3-948B-1728B52AA6E4}">
                 <adec:decorative xmlns:adec="http://schemas.microsoft.com/office/drawing/2017/decorative" val="1"/>
@@ -5424,7 +5357,7 @@
           <p:cNvPr id="11" name="Footer Placeholder 10">
             <a:extLst>
               <a:ext uri="{FF2B5EF4-FFF2-40B4-BE49-F238E27FC236}">
-                <a16:creationId xmlns:a16="http://schemas.microsoft.com/office/drawing/2014/main" id="{33A906F5-05BA-178E-74E3-33673F75239E}"/>
+                <a16:creationId xmlns:a16="http://schemas.microsoft.com/office/drawing/2014/main" id="{BB1C0603-8047-1EA8-656C-93CC9FF56BB4}"/>
               </a:ext>
             </a:extLst>
           </p:cNvPr>
@@ -5459,7 +5392,7 @@
           <p:cNvPr id="2" name="Freeform: Shape 1">
             <a:extLst>
               <a:ext uri="{FF2B5EF4-FFF2-40B4-BE49-F238E27FC236}">
-                <a16:creationId xmlns:a16="http://schemas.microsoft.com/office/drawing/2014/main" id="{B1EFF4A9-A25C-8066-1704-6A9C62D39910}"/>
+                <a16:creationId xmlns:a16="http://schemas.microsoft.com/office/drawing/2014/main" id="{6DAD8027-1835-30F1-2138-FEEFB4294F47}"/>
               </a:ext>
             </a:extLst>
           </p:cNvPr>
@@ -5574,10 +5507,10 @@
       </p:sp>
       <p:sp>
         <p:nvSpPr>
-          <p:cNvPr id="5" name="TextBox 4">
-            <a:extLst>
-              <a:ext uri="{FF2B5EF4-FFF2-40B4-BE49-F238E27FC236}">
-                <a16:creationId xmlns:a16="http://schemas.microsoft.com/office/drawing/2014/main" id="{9566E780-707B-DF0F-6D9C-7CBE09010419}"/>
+          <p:cNvPr id="4" name="TextBox 3">
+            <a:extLst>
+              <a:ext uri="{FF2B5EF4-FFF2-40B4-BE49-F238E27FC236}">
+                <a16:creationId xmlns:a16="http://schemas.microsoft.com/office/drawing/2014/main" id="{9E3EEE10-82D5-87E4-5878-1CDBB4D30E23}"/>
               </a:ext>
             </a:extLst>
           </p:cNvPr>
@@ -5586,8 +5519,8 @@
         </p:nvSpPr>
         <p:spPr>
           <a:xfrm>
-            <a:off x="462987" y="572220"/>
-            <a:ext cx="11100122" cy="7017306"/>
+            <a:off x="566057" y="572220"/>
+            <a:ext cx="3302558" cy="523220"/>
           </a:xfrm>
           <a:prstGeom prst="rect">
             <a:avLst/>
@@ -5601,15 +5534,62 @@
           <a:lstStyle/>
           <a:p>
             <a:r>
-              <a:rPr lang="en-US" sz="2400" dirty="0"/>
-              <a:t>What you need</a:t>
-            </a:r>
-          </a:p>
+              <a:rPr lang="en-US" sz="2800" dirty="0"/>
+              <a:t>Before we begin…</a:t>
+            </a:r>
+          </a:p>
+        </p:txBody>
+      </p:sp>
+      <p:sp>
+        <p:nvSpPr>
+          <p:cNvPr id="5" name="TextBox 4">
+            <a:extLst>
+              <a:ext uri="{FF2B5EF4-FFF2-40B4-BE49-F238E27FC236}">
+                <a16:creationId xmlns:a16="http://schemas.microsoft.com/office/drawing/2014/main" id="{EF36D861-DF68-5C6D-8119-18A5814B2A68}"/>
+              </a:ext>
+            </a:extLst>
+          </p:cNvPr>
+          <p:cNvSpPr txBox="1"/>
+          <p:nvPr/>
+        </p:nvSpPr>
+        <p:spPr>
+          <a:xfrm>
+            <a:off x="675249" y="1567027"/>
+            <a:ext cx="11015003" cy="2677656"/>
+          </a:xfrm>
+          <a:prstGeom prst="rect">
+            <a:avLst/>
+          </a:prstGeom>
+          <a:noFill/>
+        </p:spPr>
+        <p:txBody>
+          <a:bodyPr wrap="square" rtlCol="0">
+            <a:spAutoFit/>
+          </a:bodyPr>
+          <a:lstStyle/>
           <a:p>
             <a:pPr marL="285750" indent="-285750">
               <a:buFont typeface="Arial" panose="020B0604020202020204" pitchFamily="34" charset="0"/>
               <a:buChar char="•"/>
             </a:pPr>
+            <a:r>
+              <a:rPr lang="en-US" sz="2400" dirty="0"/>
+              <a:t>The presentation slides will be uploaded to my </a:t>
+            </a:r>
+            <a:r>
+              <a:rPr lang="en-US" sz="2400" dirty="0" err="1"/>
+              <a:t>Github</a:t>
+            </a:r>
+            <a:r>
+              <a:rPr lang="en-US" sz="2400" dirty="0"/>
+              <a:t> account at </a:t>
+            </a:r>
+            <a:r>
+              <a:rPr lang="en-US" sz="2400" dirty="0">
+                <a:hlinkClick r:id="rId3"/>
+              </a:rPr>
+              <a:t>https://github.com/knittingguy</a:t>
+            </a:r>
             <a:endParaRPr lang="en-US" sz="2400" dirty="0"/>
           </a:p>
           <a:p>
@@ -5619,7 +5599,23 @@
             </a:pPr>
             <a:r>
               <a:rPr lang="en-US" sz="2400" dirty="0"/>
-              <a:t>A codebase </a:t>
+              <a:t>Inspiration:  </a:t>
+            </a:r>
+            <a:r>
+              <a:rPr lang="en-US" sz="2400" dirty="0" err="1"/>
+              <a:t>Github</a:t>
+            </a:r>
+            <a:r>
+              <a:rPr lang="en-US" sz="2400" dirty="0"/>
+              <a:t> </a:t>
+            </a:r>
+            <a:r>
+              <a:rPr lang="en-US" sz="2400" dirty="0" err="1"/>
+              <a:t>CodeQL</a:t>
+            </a:r>
+            <a:r>
+              <a:rPr lang="en-US" sz="2400" dirty="0"/>
+              <a:t> – semantic search on your codebase.  Treating your codebase as data.  Combining the AI chat capabilities with your codebase.  Essentially, it is a poor man version of J.A.R.V.I.S. on your codebase.  </a:t>
             </a:r>
           </a:p>
           <a:p>
@@ -5629,130 +5625,18 @@
             </a:pPr>
             <a:r>
               <a:rPr lang="en-US" sz="2400" dirty="0"/>
-              <a:t>ColdFusion 2025 Update 8</a:t>
-            </a:r>
-          </a:p>
-          <a:p>
-            <a:pPr marL="285750" indent="-285750">
-              <a:buFont typeface="Arial" panose="020B0604020202020204" pitchFamily="34" charset="0"/>
-              <a:buChar char="•"/>
-            </a:pPr>
-            <a:r>
-              <a:rPr lang="en-US" sz="2400" dirty="0"/>
-              <a:t>Vector store (</a:t>
-            </a:r>
-            <a:r>
-              <a:rPr lang="en-US" sz="2400" dirty="0" err="1"/>
-              <a:t>Qdrant</a:t>
-            </a:r>
-            <a:r>
-              <a:rPr lang="en-US" sz="2400" dirty="0"/>
-              <a:t>, Milvus, Pinecone, or Chroma)</a:t>
-            </a:r>
-          </a:p>
-          <a:p>
-            <a:pPr marL="742950" lvl="1" indent="-285750">
-              <a:buFont typeface="Arial" panose="020B0604020202020204" pitchFamily="34" charset="0"/>
-              <a:buChar char="•"/>
-            </a:pPr>
-            <a:r>
-              <a:rPr lang="en-US" sz="2400" dirty="0"/>
-              <a:t>While CF 2025 supports </a:t>
-            </a:r>
-            <a:r>
-              <a:rPr lang="en-US" sz="2400" dirty="0" err="1"/>
-              <a:t>inmemory</a:t>
-            </a:r>
-            <a:r>
-              <a:rPr lang="en-US" sz="2400" dirty="0"/>
-              <a:t>, a codebase is too much information to be stored in memory </a:t>
-            </a:r>
-          </a:p>
-          <a:p>
-            <a:pPr marL="285750" indent="-285750">
-              <a:buFont typeface="Arial" panose="020B0604020202020204" pitchFamily="34" charset="0"/>
-              <a:buChar char="•"/>
-            </a:pPr>
-            <a:r>
-              <a:rPr lang="en-US" sz="2400" dirty="0"/>
-              <a:t>LLM</a:t>
-            </a:r>
-          </a:p>
-          <a:p>
-            <a:pPr marL="285750" indent="-285750">
-              <a:buFont typeface="Arial" panose="020B0604020202020204" pitchFamily="34" charset="0"/>
-              <a:buChar char="•"/>
-            </a:pPr>
-            <a:r>
-              <a:rPr lang="en-US" sz="2400" dirty="0"/>
-              <a:t>Script to ingest the codebase in a vector store.</a:t>
-            </a:r>
-          </a:p>
-          <a:p>
-            <a:pPr marL="742950" lvl="1" indent="-285750">
-              <a:buFont typeface="Arial" panose="020B0604020202020204" pitchFamily="34" charset="0"/>
-              <a:buChar char="•"/>
-            </a:pPr>
-            <a:r>
-              <a:rPr lang="en-US" sz="2400" dirty="0"/>
-              <a:t>CF 2025 has the ability to ingest different documents.  However, it cannot ingest cfc or </a:t>
-            </a:r>
-            <a:r>
-              <a:rPr lang="en-US" sz="2400" dirty="0" err="1"/>
-              <a:t>cfml</a:t>
-            </a:r>
-            <a:r>
-              <a:rPr lang="en-US" sz="2400" dirty="0"/>
-              <a:t> files yet.</a:t>
-            </a:r>
-          </a:p>
-          <a:p>
-            <a:pPr marL="285750" indent="-285750">
-              <a:buFont typeface="Arial" panose="020B0604020202020204" pitchFamily="34" charset="0"/>
-              <a:buChar char="•"/>
-            </a:pPr>
-            <a:r>
-              <a:rPr lang="en-US" sz="2400" dirty="0"/>
-              <a:t>MCP (optional)</a:t>
-            </a:r>
-          </a:p>
-          <a:p>
-            <a:pPr marL="742950" lvl="1" indent="-285750">
-              <a:buFont typeface="Arial" panose="020B0604020202020204" pitchFamily="34" charset="0"/>
-              <a:buChar char="•"/>
-            </a:pPr>
-            <a:r>
-              <a:rPr lang="en-US" sz="2400" dirty="0"/>
-              <a:t>Depending on the kind of information you may want to know, if you want to know information on the file level, you may need a MCP with access to the file information and return them to you.</a:t>
+              <a:t>“With great power comes … great self-indulgence.” --- Ben Nadel</a:t>
             </a:r>
           </a:p>
           <a:p>
             <a:endParaRPr lang="en-US" sz="2400" dirty="0"/>
-          </a:p>
-          <a:p>
-            <a:pPr lvl="1"/>
-            <a:endParaRPr lang="en-US" sz="2400" dirty="0"/>
-          </a:p>
-          <a:p>
-            <a:pPr marL="285750" indent="-285750">
-              <a:buFont typeface="Arial" panose="020B0604020202020204" pitchFamily="34" charset="0"/>
-              <a:buChar char="•"/>
-            </a:pPr>
-            <a:endParaRPr lang="en-US" sz="2400" dirty="0"/>
-          </a:p>
-          <a:p>
-            <a:pPr marL="285750" indent="-285750">
-              <a:buFont typeface="Arial" panose="020B0604020202020204" pitchFamily="34" charset="0"/>
-              <a:buChar char="•"/>
-            </a:pPr>
-            <a:endParaRPr lang="en-US" dirty="0"/>
           </a:p>
         </p:txBody>
       </p:sp>
     </p:spTree>
     <p:extLst>
       <p:ext uri="{BB962C8B-B14F-4D97-AF65-F5344CB8AC3E}">
-        <p14:creationId xmlns:p14="http://schemas.microsoft.com/office/powerpoint/2010/main" val="4265656415"/>
+        <p14:creationId xmlns:p14="http://schemas.microsoft.com/office/powerpoint/2010/main" val="3212058639"/>
       </p:ext>
     </p:extLst>
   </p:cSld>
@@ -5762,7 +5646,7 @@
 </p:sld>
 </file>
 
-<file path=ppt/slides/slide5.xml><?xml version="1.0" encoding="utf-8"?>
+<file path=ppt/slides/slide4.xml><?xml version="1.0" encoding="utf-8"?>
 <p:sld xmlns:a="http://schemas.openxmlformats.org/drawingml/2006/main" xmlns:r="http://schemas.openxmlformats.org/officeDocument/2006/relationships" xmlns:p="http://schemas.openxmlformats.org/presentationml/2006/main">
   <p:cSld>
     <p:bg>
@@ -5778,7 +5662,7 @@
         <p:cNvPr id="1" name="">
           <a:extLst>
             <a:ext uri="{FF2B5EF4-FFF2-40B4-BE49-F238E27FC236}">
-              <a16:creationId xmlns:a16="http://schemas.microsoft.com/office/drawing/2014/main" id="{9BACDD77-074D-B497-3DCC-1F970C3EC634}"/>
+              <a16:creationId xmlns:a16="http://schemas.microsoft.com/office/drawing/2014/main" id="{0530EB7F-C55B-6176-476A-12CF24B64E17}"/>
             </a:ext>
           </a:extLst>
         </p:cNvPr>
@@ -5798,7 +5682,7 @@
           <p:cNvPr id="12" name="Picture 11">
             <a:extLst>
               <a:ext uri="{FF2B5EF4-FFF2-40B4-BE49-F238E27FC236}">
-                <a16:creationId xmlns:a16="http://schemas.microsoft.com/office/drawing/2014/main" id="{DB6BCF8E-2D86-A22F-3A5D-3032FBD0E478}"/>
+                <a16:creationId xmlns:a16="http://schemas.microsoft.com/office/drawing/2014/main" id="{56A4C503-754C-F836-01FF-8441F9802EC0}"/>
               </a:ext>
             </a:extLst>
           </p:cNvPr>
@@ -5828,7 +5712,7 @@
           <p:cNvPr id="10" name="Rectangle 9">
             <a:extLst>
               <a:ext uri="{FF2B5EF4-FFF2-40B4-BE49-F238E27FC236}">
-                <a16:creationId xmlns:a16="http://schemas.microsoft.com/office/drawing/2014/main" id="{0DA2AD64-C519-4512-C5E6-8829BE962DEC}"/>
+                <a16:creationId xmlns:a16="http://schemas.microsoft.com/office/drawing/2014/main" id="{CFE8CFDD-9079-B347-F4CB-9B6B0348403D}"/>
               </a:ext>
               <a:ext uri="{C183D7F6-B498-43B3-948B-1728B52AA6E4}">
                 <adec:decorative xmlns:adec="http://schemas.microsoft.com/office/drawing/2017/decorative" val="1"/>
@@ -5983,7 +5867,7 @@
           <p:cNvPr id="11" name="Footer Placeholder 10">
             <a:extLst>
               <a:ext uri="{FF2B5EF4-FFF2-40B4-BE49-F238E27FC236}">
-                <a16:creationId xmlns:a16="http://schemas.microsoft.com/office/drawing/2014/main" id="{0EBE153E-E3B0-59CC-C25A-5605B1080D4F}"/>
+                <a16:creationId xmlns:a16="http://schemas.microsoft.com/office/drawing/2014/main" id="{33A906F5-05BA-178E-74E3-33673F75239E}"/>
               </a:ext>
             </a:extLst>
           </p:cNvPr>
@@ -6018,7 +5902,7 @@
           <p:cNvPr id="2" name="Freeform: Shape 1">
             <a:extLst>
               <a:ext uri="{FF2B5EF4-FFF2-40B4-BE49-F238E27FC236}">
-                <a16:creationId xmlns:a16="http://schemas.microsoft.com/office/drawing/2014/main" id="{DD656C1C-7E04-1309-ACC8-735E1BDC6A54}"/>
+                <a16:creationId xmlns:a16="http://schemas.microsoft.com/office/drawing/2014/main" id="{B1EFF4A9-A25C-8066-1704-6A9C62D39910}"/>
               </a:ext>
             </a:extLst>
           </p:cNvPr>
@@ -6136,7 +6020,7 @@
           <p:cNvPr id="5" name="TextBox 4">
             <a:extLst>
               <a:ext uri="{FF2B5EF4-FFF2-40B4-BE49-F238E27FC236}">
-                <a16:creationId xmlns:a16="http://schemas.microsoft.com/office/drawing/2014/main" id="{A7DDAF17-4F15-D220-62B5-7D8BE8435D46}"/>
+                <a16:creationId xmlns:a16="http://schemas.microsoft.com/office/drawing/2014/main" id="{9566E780-707B-DF0F-6D9C-7CBE09010419}"/>
               </a:ext>
             </a:extLst>
           </p:cNvPr>
@@ -6146,7 +6030,7 @@
         <p:spPr>
           <a:xfrm>
             <a:off x="462987" y="572220"/>
-            <a:ext cx="11100122" cy="3693319"/>
+            <a:ext cx="11100122" cy="7386638"/>
           </a:xfrm>
           <a:prstGeom prst="rect">
             <a:avLst/>
@@ -6159,6 +6043,12 @@
           </a:bodyPr>
           <a:lstStyle/>
           <a:p>
+            <a:r>
+              <a:rPr lang="en-US" sz="2400" dirty="0"/>
+              <a:t>What you need</a:t>
+            </a:r>
+          </a:p>
+          <a:p>
             <a:pPr marL="285750" indent="-285750">
               <a:buFont typeface="Arial" panose="020B0604020202020204" pitchFamily="34" charset="0"/>
               <a:buChar char="•"/>
@@ -6172,7 +6062,35 @@
             </a:pPr>
             <a:r>
               <a:rPr lang="en-US" sz="2400" dirty="0"/>
-              <a:t>MCP (continued)</a:t>
+              <a:t>A codebase </a:t>
+            </a:r>
+          </a:p>
+          <a:p>
+            <a:pPr marL="285750" indent="-285750">
+              <a:buFont typeface="Arial" panose="020B0604020202020204" pitchFamily="34" charset="0"/>
+              <a:buChar char="•"/>
+            </a:pPr>
+            <a:r>
+              <a:rPr lang="en-US" sz="2400" dirty="0"/>
+              <a:t>ColdFusion 2025 Update 8</a:t>
+            </a:r>
+          </a:p>
+          <a:p>
+            <a:pPr marL="285750" indent="-285750">
+              <a:buFont typeface="Arial" panose="020B0604020202020204" pitchFamily="34" charset="0"/>
+              <a:buChar char="•"/>
+            </a:pPr>
+            <a:r>
+              <a:rPr lang="en-US" sz="2400" dirty="0"/>
+              <a:t>Vector store (</a:t>
+            </a:r>
+            <a:r>
+              <a:rPr lang="en-US" sz="2400" dirty="0" err="1"/>
+              <a:t>Qdrant</a:t>
+            </a:r>
+            <a:r>
+              <a:rPr lang="en-US" sz="2400" dirty="0"/>
+              <a:t>, Milvus, Pinecone, or Chroma)</a:t>
             </a:r>
           </a:p>
           <a:p>
@@ -6182,15 +6100,36 @@
             </a:pPr>
             <a:r>
               <a:rPr lang="en-US" sz="2400" dirty="0"/>
-              <a:t>MCP server list </a:t>
-            </a:r>
-            <a:r>
-              <a:rPr lang="en-US" sz="2400" dirty="0">
-                <a:hlinkClick r:id="rId3"/>
-              </a:rPr>
-              <a:t>https://mcpservers.org/</a:t>
-            </a:r>
-            <a:endParaRPr lang="en-US" sz="2400" dirty="0"/>
+              <a:t>While CF 2025 supports </a:t>
+            </a:r>
+            <a:r>
+              <a:rPr lang="en-US" sz="2400" dirty="0" err="1"/>
+              <a:t>inmemory</a:t>
+            </a:r>
+            <a:r>
+              <a:rPr lang="en-US" sz="2400" dirty="0"/>
+              <a:t>, a codebase is too much information to be stored in memory </a:t>
+            </a:r>
+          </a:p>
+          <a:p>
+            <a:pPr marL="285750" indent="-285750">
+              <a:buFont typeface="Arial" panose="020B0604020202020204" pitchFamily="34" charset="0"/>
+              <a:buChar char="•"/>
+            </a:pPr>
+            <a:r>
+              <a:rPr lang="en-US" sz="2400" dirty="0"/>
+              <a:t>LLM</a:t>
+            </a:r>
+          </a:p>
+          <a:p>
+            <a:pPr marL="285750" indent="-285750">
+              <a:buFont typeface="Arial" panose="020B0604020202020204" pitchFamily="34" charset="0"/>
+              <a:buChar char="•"/>
+            </a:pPr>
+            <a:r>
+              <a:rPr lang="en-US" sz="2400" dirty="0"/>
+              <a:t>Script to ingest the codebase in a vector store.</a:t>
+            </a:r>
           </a:p>
           <a:p>
             <a:pPr marL="742950" lvl="1" indent="-285750">
@@ -6199,29 +6138,46 @@
             </a:pPr>
             <a:r>
               <a:rPr lang="en-US" sz="2400" dirty="0"/>
-              <a:t>For example, </a:t>
-            </a:r>
-            <a:r>
-              <a:rPr lang="en-US" sz="2400" dirty="0">
-                <a:hlinkClick r:id="rId4"/>
-              </a:rPr>
-              <a:t>https://mcpservers.org/servers/mark3labs/mcp-filesystem-server</a:t>
-            </a:r>
-            <a:endParaRPr lang="en-US" sz="2400" dirty="0"/>
+              <a:t>CF 2025 has the ability to ingest different documents.  However, it cannot ingest cfc or </a:t>
+            </a:r>
+            <a:r>
+              <a:rPr lang="en-US" sz="2400" dirty="0" err="1"/>
+              <a:t>cfml</a:t>
+            </a:r>
+            <a:r>
+              <a:rPr lang="en-US" sz="2400" dirty="0"/>
+              <a:t> files yet.</a:t>
+            </a:r>
           </a:p>
           <a:p>
             <a:pPr marL="742950" lvl="1" indent="-285750">
               <a:buFont typeface="Arial" panose="020B0604020202020204" pitchFamily="34" charset="0"/>
               <a:buChar char="•"/>
             </a:pPr>
-            <a:endParaRPr lang="en-US" sz="2400" dirty="0"/>
+            <a:r>
+              <a:rPr lang="en-US" sz="2400" dirty="0"/>
+              <a:t>Instead of ingesting the codes, you can insert the data into a vector store.</a:t>
+            </a:r>
+          </a:p>
+          <a:p>
+            <a:pPr marL="285750" indent="-285750">
+              <a:buFont typeface="Arial" panose="020B0604020202020204" pitchFamily="34" charset="0"/>
+              <a:buChar char="•"/>
+            </a:pPr>
+            <a:r>
+              <a:rPr lang="en-US" sz="2400" dirty="0"/>
+              <a:t>MCP (optional)</a:t>
+            </a:r>
           </a:p>
           <a:p>
             <a:pPr marL="742950" lvl="1" indent="-285750">
               <a:buFont typeface="Arial" panose="020B0604020202020204" pitchFamily="34" charset="0"/>
               <a:buChar char="•"/>
             </a:pPr>
-            <a:endParaRPr lang="en-US" sz="2400" dirty="0"/>
+            <a:r>
+              <a:rPr lang="en-US" sz="2400" dirty="0"/>
+              <a:t>Depending on the kind of information you may want to know, if you want to know information on the file level, you may need a MCP with access to the file information and return them to you.</a:t>
+            </a:r>
           </a:p>
           <a:p>
             <a:endParaRPr lang="en-US" sz="2400" dirty="0"/>
@@ -6249,7 +6205,7 @@
     </p:spTree>
     <p:extLst>
       <p:ext uri="{BB962C8B-B14F-4D97-AF65-F5344CB8AC3E}">
-        <p14:creationId xmlns:p14="http://schemas.microsoft.com/office/powerpoint/2010/main" val="2836684089"/>
+        <p14:creationId xmlns:p14="http://schemas.microsoft.com/office/powerpoint/2010/main" val="4265656415"/>
       </p:ext>
     </p:extLst>
   </p:cSld>
@@ -6259,7 +6215,7 @@
 </p:sld>
 </file>
 
-<file path=ppt/slides/slide6.xml><?xml version="1.0" encoding="utf-8"?>
+<file path=ppt/slides/slide5.xml><?xml version="1.0" encoding="utf-8"?>
 <p:sld xmlns:a="http://schemas.openxmlformats.org/drawingml/2006/main" xmlns:r="http://schemas.openxmlformats.org/officeDocument/2006/relationships" xmlns:p="http://schemas.openxmlformats.org/presentationml/2006/main">
   <p:cSld>
     <p:bg>
@@ -6275,7 +6231,7 @@
         <p:cNvPr id="1" name="">
           <a:extLst>
             <a:ext uri="{FF2B5EF4-FFF2-40B4-BE49-F238E27FC236}">
-              <a16:creationId xmlns:a16="http://schemas.microsoft.com/office/drawing/2014/main" id="{B6C8F673-4CCB-2A3F-6B76-9D43763DBBC1}"/>
+              <a16:creationId xmlns:a16="http://schemas.microsoft.com/office/drawing/2014/main" id="{9BACDD77-074D-B497-3DCC-1F970C3EC634}"/>
             </a:ext>
           </a:extLst>
         </p:cNvPr>
@@ -6295,7 +6251,7 @@
           <p:cNvPr id="12" name="Picture 11">
             <a:extLst>
               <a:ext uri="{FF2B5EF4-FFF2-40B4-BE49-F238E27FC236}">
-                <a16:creationId xmlns:a16="http://schemas.microsoft.com/office/drawing/2014/main" id="{55678A6E-C105-66F0-EAFE-D4338F2DC027}"/>
+                <a16:creationId xmlns:a16="http://schemas.microsoft.com/office/drawing/2014/main" id="{DB6BCF8E-2D86-A22F-3A5D-3032FBD0E478}"/>
               </a:ext>
             </a:extLst>
           </p:cNvPr>
@@ -6325,7 +6281,7 @@
           <p:cNvPr id="10" name="Rectangle 9">
             <a:extLst>
               <a:ext uri="{FF2B5EF4-FFF2-40B4-BE49-F238E27FC236}">
-                <a16:creationId xmlns:a16="http://schemas.microsoft.com/office/drawing/2014/main" id="{2FB3C455-F41F-5B4D-C779-E672F512D805}"/>
+                <a16:creationId xmlns:a16="http://schemas.microsoft.com/office/drawing/2014/main" id="{0DA2AD64-C519-4512-C5E6-8829BE962DEC}"/>
               </a:ext>
               <a:ext uri="{C183D7F6-B498-43B3-948B-1728B52AA6E4}">
                 <adec:decorative xmlns:adec="http://schemas.microsoft.com/office/drawing/2017/decorative" val="1"/>
@@ -6480,7 +6436,7 @@
           <p:cNvPr id="11" name="Footer Placeholder 10">
             <a:extLst>
               <a:ext uri="{FF2B5EF4-FFF2-40B4-BE49-F238E27FC236}">
-                <a16:creationId xmlns:a16="http://schemas.microsoft.com/office/drawing/2014/main" id="{8C615996-C118-1838-FCB1-0D027E0D5B41}"/>
+                <a16:creationId xmlns:a16="http://schemas.microsoft.com/office/drawing/2014/main" id="{0EBE153E-E3B0-59CC-C25A-5605B1080D4F}"/>
               </a:ext>
             </a:extLst>
           </p:cNvPr>
@@ -6515,7 +6471,7 @@
           <p:cNvPr id="2" name="Freeform: Shape 1">
             <a:extLst>
               <a:ext uri="{FF2B5EF4-FFF2-40B4-BE49-F238E27FC236}">
-                <a16:creationId xmlns:a16="http://schemas.microsoft.com/office/drawing/2014/main" id="{411D29B7-B379-F6C8-D4C2-90412C89DC0D}"/>
+                <a16:creationId xmlns:a16="http://schemas.microsoft.com/office/drawing/2014/main" id="{DD656C1C-7E04-1309-ACC8-735E1BDC6A54}"/>
               </a:ext>
             </a:extLst>
           </p:cNvPr>
@@ -6633,7 +6589,7 @@
           <p:cNvPr id="5" name="TextBox 4">
             <a:extLst>
               <a:ext uri="{FF2B5EF4-FFF2-40B4-BE49-F238E27FC236}">
-                <a16:creationId xmlns:a16="http://schemas.microsoft.com/office/drawing/2014/main" id="{CCC1E398-E049-CD9D-0784-E168464E0A39}"/>
+                <a16:creationId xmlns:a16="http://schemas.microsoft.com/office/drawing/2014/main" id="{A7DDAF17-4F15-D220-62B5-7D8BE8435D46}"/>
               </a:ext>
             </a:extLst>
           </p:cNvPr>
@@ -6643,7 +6599,7 @@
         <p:spPr>
           <a:xfrm>
             <a:off x="462987" y="572220"/>
-            <a:ext cx="11100122" cy="6278642"/>
+            <a:ext cx="11100122" cy="3693319"/>
           </a:xfrm>
           <a:prstGeom prst="rect">
             <a:avLst/>
@@ -6663,9 +6619,13 @@
             <a:endParaRPr lang="en-US" sz="2400" dirty="0"/>
           </a:p>
           <a:p>
+            <a:pPr marL="285750" indent="-285750">
+              <a:buFont typeface="Arial" panose="020B0604020202020204" pitchFamily="34" charset="0"/>
+              <a:buChar char="•"/>
+            </a:pPr>
             <a:r>
               <a:rPr lang="en-US" sz="2400" dirty="0"/>
-              <a:t>Vector Store</a:t>
+              <a:t>MCP (continued)</a:t>
             </a:r>
           </a:p>
           <a:p>
@@ -6675,6 +6635,499 @@
             </a:pPr>
             <a:r>
               <a:rPr lang="en-US" sz="2400" dirty="0"/>
+              <a:t>MCP server list </a:t>
+            </a:r>
+            <a:r>
+              <a:rPr lang="en-US" sz="2400" dirty="0">
+                <a:hlinkClick r:id="rId3"/>
+              </a:rPr>
+              <a:t>https://mcpservers.org/</a:t>
+            </a:r>
+            <a:endParaRPr lang="en-US" sz="2400" dirty="0"/>
+          </a:p>
+          <a:p>
+            <a:pPr marL="742950" lvl="1" indent="-285750">
+              <a:buFont typeface="Arial" panose="020B0604020202020204" pitchFamily="34" charset="0"/>
+              <a:buChar char="•"/>
+            </a:pPr>
+            <a:r>
+              <a:rPr lang="en-US" sz="2400" dirty="0"/>
+              <a:t>For example, </a:t>
+            </a:r>
+            <a:r>
+              <a:rPr lang="en-US" sz="2400" dirty="0">
+                <a:hlinkClick r:id="rId4"/>
+              </a:rPr>
+              <a:t>https://mcpservers.org/servers/mark3labs/mcp-filesystem-server</a:t>
+            </a:r>
+            <a:endParaRPr lang="en-US" sz="2400" dirty="0"/>
+          </a:p>
+          <a:p>
+            <a:pPr marL="742950" lvl="1" indent="-285750">
+              <a:buFont typeface="Arial" panose="020B0604020202020204" pitchFamily="34" charset="0"/>
+              <a:buChar char="•"/>
+            </a:pPr>
+            <a:endParaRPr lang="en-US" sz="2400" dirty="0"/>
+          </a:p>
+          <a:p>
+            <a:pPr marL="742950" lvl="1" indent="-285750">
+              <a:buFont typeface="Arial" panose="020B0604020202020204" pitchFamily="34" charset="0"/>
+              <a:buChar char="•"/>
+            </a:pPr>
+            <a:endParaRPr lang="en-US" sz="2400" dirty="0"/>
+          </a:p>
+          <a:p>
+            <a:endParaRPr lang="en-US" sz="2400" dirty="0"/>
+          </a:p>
+          <a:p>
+            <a:pPr lvl="1"/>
+            <a:endParaRPr lang="en-US" sz="2400" dirty="0"/>
+          </a:p>
+          <a:p>
+            <a:pPr marL="285750" indent="-285750">
+              <a:buFont typeface="Arial" panose="020B0604020202020204" pitchFamily="34" charset="0"/>
+              <a:buChar char="•"/>
+            </a:pPr>
+            <a:endParaRPr lang="en-US" sz="2400" dirty="0"/>
+          </a:p>
+          <a:p>
+            <a:pPr marL="285750" indent="-285750">
+              <a:buFont typeface="Arial" panose="020B0604020202020204" pitchFamily="34" charset="0"/>
+              <a:buChar char="•"/>
+            </a:pPr>
+            <a:endParaRPr lang="en-US" dirty="0"/>
+          </a:p>
+        </p:txBody>
+      </p:sp>
+    </p:spTree>
+    <p:extLst>
+      <p:ext uri="{BB962C8B-B14F-4D97-AF65-F5344CB8AC3E}">
+        <p14:creationId xmlns:p14="http://schemas.microsoft.com/office/powerpoint/2010/main" val="2836684089"/>
+      </p:ext>
+    </p:extLst>
+  </p:cSld>
+  <p:clrMapOvr>
+    <a:masterClrMapping/>
+  </p:clrMapOvr>
+</p:sld>
+</file>
+
+<file path=ppt/slides/slide6.xml><?xml version="1.0" encoding="utf-8"?>
+<p:sld xmlns:a="http://schemas.openxmlformats.org/drawingml/2006/main" xmlns:r="http://schemas.openxmlformats.org/officeDocument/2006/relationships" xmlns:p="http://schemas.openxmlformats.org/presentationml/2006/main">
+  <p:cSld>
+    <p:bg>
+      <p:bgPr>
+        <a:solidFill>
+          <a:schemeClr val="bg1"/>
+        </a:solidFill>
+        <a:effectLst/>
+      </p:bgPr>
+    </p:bg>
+    <p:spTree>
+      <p:nvGrpSpPr>
+        <p:cNvPr id="1" name="">
+          <a:extLst>
+            <a:ext uri="{FF2B5EF4-FFF2-40B4-BE49-F238E27FC236}">
+              <a16:creationId xmlns:a16="http://schemas.microsoft.com/office/drawing/2014/main" id="{B6C8F673-4CCB-2A3F-6B76-9D43763DBBC1}"/>
+            </a:ext>
+          </a:extLst>
+        </p:cNvPr>
+        <p:cNvGrpSpPr/>
+        <p:nvPr/>
+      </p:nvGrpSpPr>
+      <p:grpSpPr>
+        <a:xfrm>
+          <a:off x="0" y="0"/>
+          <a:ext cx="0" cy="0"/>
+          <a:chOff x="0" y="0"/>
+          <a:chExt cx="0" cy="0"/>
+        </a:xfrm>
+      </p:grpSpPr>
+      <p:pic>
+        <p:nvPicPr>
+          <p:cNvPr id="12" name="Picture 11">
+            <a:extLst>
+              <a:ext uri="{FF2B5EF4-FFF2-40B4-BE49-F238E27FC236}">
+                <a16:creationId xmlns:a16="http://schemas.microsoft.com/office/drawing/2014/main" id="{55678A6E-C105-66F0-EAFE-D4338F2DC027}"/>
+              </a:ext>
+            </a:extLst>
+          </p:cNvPr>
+          <p:cNvPicPr>
+            <a:picLocks noChangeAspect="1"/>
+          </p:cNvPicPr>
+          <p:nvPr/>
+        </p:nvPicPr>
+        <p:blipFill>
+          <a:blip r:embed="rId2"/>
+          <a:stretch>
+            <a:fillRect/>
+          </a:stretch>
+        </p:blipFill>
+        <p:spPr>
+          <a:xfrm>
+            <a:off x="-11151" y="-6271"/>
+            <a:ext cx="12188952" cy="6864271"/>
+          </a:xfrm>
+          <a:prstGeom prst="rect">
+            <a:avLst/>
+          </a:prstGeom>
+        </p:spPr>
+      </p:pic>
+      <p:sp>
+        <p:nvSpPr>
+          <p:cNvPr id="10" name="Rectangle 9">
+            <a:extLst>
+              <a:ext uri="{FF2B5EF4-FFF2-40B4-BE49-F238E27FC236}">
+                <a16:creationId xmlns:a16="http://schemas.microsoft.com/office/drawing/2014/main" id="{2FB3C455-F41F-5B4D-C779-E672F512D805}"/>
+              </a:ext>
+              <a:ext uri="{C183D7F6-B498-43B3-948B-1728B52AA6E4}">
+                <adec:decorative xmlns:adec="http://schemas.microsoft.com/office/drawing/2017/decorative" val="1"/>
+              </a:ext>
+            </a:extLst>
+          </p:cNvPr>
+          <p:cNvSpPr>
+            <a:spLocks noGrp="1" noRot="1" noChangeAspect="1" noMove="1" noResize="1" noEditPoints="1" noAdjustHandles="1" noChangeArrowheads="1" noChangeShapeType="1" noTextEdit="1"/>
+          </p:cNvSpPr>
+          <p:nvPr>
+            <p:extLst>
+              <p:ext uri="{386F3935-93C4-4BCD-93E2-E3B085C9AB24}">
+                <p16:designElem xmlns:p16="http://schemas.microsoft.com/office/powerpoint/2015/main" val="1"/>
+              </p:ext>
+            </p:extLst>
+          </p:nvPr>
+        </p:nvSpPr>
+        <p:spPr bwMode="white">
+          <a:xfrm>
+            <a:off x="1524" y="0"/>
+            <a:ext cx="12188952" cy="6858000"/>
+          </a:xfrm>
+          <a:prstGeom prst="rect">
+            <a:avLst/>
+          </a:prstGeom>
+          <a:noFill/>
+          <a:ln>
+            <a:noFill/>
+          </a:ln>
+        </p:spPr>
+        <p:style>
+          <a:lnRef idx="2">
+            <a:schemeClr val="accent1">
+              <a:shade val="50000"/>
+            </a:schemeClr>
+          </a:lnRef>
+          <a:fillRef idx="1">
+            <a:schemeClr val="accent1"/>
+          </a:fillRef>
+          <a:effectRef idx="0">
+            <a:schemeClr val="accent1"/>
+          </a:effectRef>
+          <a:fontRef idx="minor">
+            <a:schemeClr val="lt1"/>
+          </a:fontRef>
+        </p:style>
+        <p:txBody>
+          <a:bodyPr rtlCol="0" anchor="ctr"/>
+          <a:lstStyle>
+            <a:defPPr>
+              <a:defRPr lang="en-US"/>
+            </a:defPPr>
+            <a:lvl1pPr marL="0" algn="l" defTabSz="914400" rtl="0" eaLnBrk="1" latinLnBrk="0" hangingPunct="1">
+              <a:defRPr sz="1800" kern="1200">
+                <a:solidFill>
+                  <a:schemeClr val="lt1"/>
+                </a:solidFill>
+                <a:latin typeface="+mn-lt"/>
+                <a:ea typeface="+mn-ea"/>
+                <a:cs typeface="+mn-cs"/>
+              </a:defRPr>
+            </a:lvl1pPr>
+            <a:lvl2pPr marL="457200" algn="l" defTabSz="914400" rtl="0" eaLnBrk="1" latinLnBrk="0" hangingPunct="1">
+              <a:defRPr sz="1800" kern="1200">
+                <a:solidFill>
+                  <a:schemeClr val="lt1"/>
+                </a:solidFill>
+                <a:latin typeface="+mn-lt"/>
+                <a:ea typeface="+mn-ea"/>
+                <a:cs typeface="+mn-cs"/>
+              </a:defRPr>
+            </a:lvl2pPr>
+            <a:lvl3pPr marL="914400" algn="l" defTabSz="914400" rtl="0" eaLnBrk="1" latinLnBrk="0" hangingPunct="1">
+              <a:defRPr sz="1800" kern="1200">
+                <a:solidFill>
+                  <a:schemeClr val="lt1"/>
+                </a:solidFill>
+                <a:latin typeface="+mn-lt"/>
+                <a:ea typeface="+mn-ea"/>
+                <a:cs typeface="+mn-cs"/>
+              </a:defRPr>
+            </a:lvl3pPr>
+            <a:lvl4pPr marL="1371600" algn="l" defTabSz="914400" rtl="0" eaLnBrk="1" latinLnBrk="0" hangingPunct="1">
+              <a:defRPr sz="1800" kern="1200">
+                <a:solidFill>
+                  <a:schemeClr val="lt1"/>
+                </a:solidFill>
+                <a:latin typeface="+mn-lt"/>
+                <a:ea typeface="+mn-ea"/>
+                <a:cs typeface="+mn-cs"/>
+              </a:defRPr>
+            </a:lvl4pPr>
+            <a:lvl5pPr marL="1828800" algn="l" defTabSz="914400" rtl="0" eaLnBrk="1" latinLnBrk="0" hangingPunct="1">
+              <a:defRPr sz="1800" kern="1200">
+                <a:solidFill>
+                  <a:schemeClr val="lt1"/>
+                </a:solidFill>
+                <a:latin typeface="+mn-lt"/>
+                <a:ea typeface="+mn-ea"/>
+                <a:cs typeface="+mn-cs"/>
+              </a:defRPr>
+            </a:lvl5pPr>
+            <a:lvl6pPr marL="2286000" algn="l" defTabSz="914400" rtl="0" eaLnBrk="1" latinLnBrk="0" hangingPunct="1">
+              <a:defRPr sz="1800" kern="1200">
+                <a:solidFill>
+                  <a:schemeClr val="lt1"/>
+                </a:solidFill>
+                <a:latin typeface="+mn-lt"/>
+                <a:ea typeface="+mn-ea"/>
+                <a:cs typeface="+mn-cs"/>
+              </a:defRPr>
+            </a:lvl6pPr>
+            <a:lvl7pPr marL="2743200" algn="l" defTabSz="914400" rtl="0" eaLnBrk="1" latinLnBrk="0" hangingPunct="1">
+              <a:defRPr sz="1800" kern="1200">
+                <a:solidFill>
+                  <a:schemeClr val="lt1"/>
+                </a:solidFill>
+                <a:latin typeface="+mn-lt"/>
+                <a:ea typeface="+mn-ea"/>
+                <a:cs typeface="+mn-cs"/>
+              </a:defRPr>
+            </a:lvl7pPr>
+            <a:lvl8pPr marL="3200400" algn="l" defTabSz="914400" rtl="0" eaLnBrk="1" latinLnBrk="0" hangingPunct="1">
+              <a:defRPr sz="1800" kern="1200">
+                <a:solidFill>
+                  <a:schemeClr val="lt1"/>
+                </a:solidFill>
+                <a:latin typeface="+mn-lt"/>
+                <a:ea typeface="+mn-ea"/>
+                <a:cs typeface="+mn-cs"/>
+              </a:defRPr>
+            </a:lvl8pPr>
+            <a:lvl9pPr marL="3657600" algn="l" defTabSz="914400" rtl="0" eaLnBrk="1" latinLnBrk="0" hangingPunct="1">
+              <a:defRPr sz="1800" kern="1200">
+                <a:solidFill>
+                  <a:schemeClr val="lt1"/>
+                </a:solidFill>
+                <a:latin typeface="+mn-lt"/>
+                <a:ea typeface="+mn-ea"/>
+                <a:cs typeface="+mn-cs"/>
+              </a:defRPr>
+            </a:lvl9pPr>
+          </a:lstStyle>
+          <a:p>
+            <a:pPr algn="ctr"/>
+            <a:endParaRPr lang="en-US"/>
+          </a:p>
+        </p:txBody>
+      </p:sp>
+      <p:sp>
+        <p:nvSpPr>
+          <p:cNvPr id="11" name="Footer Placeholder 10">
+            <a:extLst>
+              <a:ext uri="{FF2B5EF4-FFF2-40B4-BE49-F238E27FC236}">
+                <a16:creationId xmlns:a16="http://schemas.microsoft.com/office/drawing/2014/main" id="{8C615996-C118-1838-FCB1-0D027E0D5B41}"/>
+              </a:ext>
+            </a:extLst>
+          </p:cNvPr>
+          <p:cNvSpPr>
+            <a:spLocks noGrp="1"/>
+          </p:cNvSpPr>
+          <p:nvPr>
+            <p:ph type="ftr" sz="quarter" idx="11"/>
+          </p:nvPr>
+        </p:nvSpPr>
+        <p:spPr>
+          <a:xfrm>
+            <a:off x="8696325" y="6462298"/>
+            <a:ext cx="4114800" cy="365125"/>
+          </a:xfrm>
+        </p:spPr>
+        <p:txBody>
+          <a:bodyPr/>
+          <a:lstStyle/>
+          <a:p>
+            <a:r>
+              <a:rPr lang="en-US" sz="1400" dirty="0">
+                <a:latin typeface="DunbarTall" panose="00000000000000020000" pitchFamily="50" charset="0"/>
+              </a:rPr>
+              <a:t>	 </a:t>
+            </a:r>
+          </a:p>
+        </p:txBody>
+      </p:sp>
+      <p:sp>
+        <p:nvSpPr>
+          <p:cNvPr id="2" name="Freeform: Shape 1">
+            <a:extLst>
+              <a:ext uri="{FF2B5EF4-FFF2-40B4-BE49-F238E27FC236}">
+                <a16:creationId xmlns:a16="http://schemas.microsoft.com/office/drawing/2014/main" id="{411D29B7-B379-F6C8-D4C2-90412C89DC0D}"/>
+              </a:ext>
+            </a:extLst>
+          </p:cNvPr>
+          <p:cNvSpPr/>
+          <p:nvPr/>
+        </p:nvSpPr>
+        <p:spPr>
+          <a:xfrm>
+            <a:off x="-11151" y="5700713"/>
+            <a:ext cx="12243125" cy="585067"/>
+          </a:xfrm>
+          <a:custGeom>
+            <a:avLst/>
+            <a:gdLst>
+              <a:gd name="connsiteX0" fmla="*/ 0 w 12243125"/>
+              <a:gd name="connsiteY0" fmla="*/ 186706 h 2145814"/>
+              <a:gd name="connsiteX1" fmla="*/ 3880624 w 12243125"/>
+              <a:gd name="connsiteY1" fmla="*/ 186706 h 2145814"/>
+              <a:gd name="connsiteX2" fmla="*/ 9088244 w 12243125"/>
+              <a:gd name="connsiteY2" fmla="*/ 2127018 h 2145814"/>
+              <a:gd name="connsiteX3" fmla="*/ 11976410 w 12243125"/>
+              <a:gd name="connsiteY3" fmla="*/ 1223770 h 2145814"/>
+              <a:gd name="connsiteX4" fmla="*/ 12132527 w 12243125"/>
+              <a:gd name="connsiteY4" fmla="*/ 1179165 h 2145814"/>
+              <a:gd name="connsiteX5" fmla="*/ 12132527 w 12243125"/>
+              <a:gd name="connsiteY5" fmla="*/ 1190316 h 2145814"/>
+            </a:gdLst>
+            <a:ahLst/>
+            <a:cxnLst>
+              <a:cxn ang="0">
+                <a:pos x="connsiteX0" y="connsiteY0"/>
+              </a:cxn>
+              <a:cxn ang="0">
+                <a:pos x="connsiteX1" y="connsiteY1"/>
+              </a:cxn>
+              <a:cxn ang="0">
+                <a:pos x="connsiteX2" y="connsiteY2"/>
+              </a:cxn>
+              <a:cxn ang="0">
+                <a:pos x="connsiteX3" y="connsiteY3"/>
+              </a:cxn>
+              <a:cxn ang="0">
+                <a:pos x="connsiteX4" y="connsiteY4"/>
+              </a:cxn>
+              <a:cxn ang="0">
+                <a:pos x="connsiteX5" y="connsiteY5"/>
+              </a:cxn>
+            </a:cxnLst>
+            <a:rect l="l" t="t" r="r" b="b"/>
+            <a:pathLst>
+              <a:path w="12243125" h="2145814">
+                <a:moveTo>
+                  <a:pt x="0" y="186706"/>
+                </a:moveTo>
+                <a:cubicBezTo>
+                  <a:pt x="1182958" y="25013"/>
+                  <a:pt x="2365917" y="-136679"/>
+                  <a:pt x="3880624" y="186706"/>
+                </a:cubicBezTo>
+                <a:cubicBezTo>
+                  <a:pt x="5395331" y="510091"/>
+                  <a:pt x="7738946" y="1954174"/>
+                  <a:pt x="9088244" y="2127018"/>
+                </a:cubicBezTo>
+                <a:cubicBezTo>
+                  <a:pt x="10437542" y="2299862"/>
+                  <a:pt x="11976410" y="1223770"/>
+                  <a:pt x="11976410" y="1223770"/>
+                </a:cubicBezTo>
+                <a:cubicBezTo>
+                  <a:pt x="12483791" y="1065795"/>
+                  <a:pt x="12106508" y="1184741"/>
+                  <a:pt x="12132527" y="1179165"/>
+                </a:cubicBezTo>
+                <a:cubicBezTo>
+                  <a:pt x="12158547" y="1173589"/>
+                  <a:pt x="12145537" y="1181952"/>
+                  <a:pt x="12132527" y="1190316"/>
+                </a:cubicBezTo>
+              </a:path>
+            </a:pathLst>
+          </a:custGeom>
+          <a:noFill/>
+          <a:effectLst>
+            <a:reflection blurRad="6350" stA="53000" endPos="35000" dir="5400000" sy="-100000" algn="bl" rotWithShape="0"/>
+          </a:effectLst>
+        </p:spPr>
+        <p:style>
+          <a:lnRef idx="2">
+            <a:schemeClr val="accent1">
+              <a:shade val="15000"/>
+            </a:schemeClr>
+          </a:lnRef>
+          <a:fillRef idx="1">
+            <a:schemeClr val="accent1"/>
+          </a:fillRef>
+          <a:effectRef idx="0">
+            <a:schemeClr val="accent1"/>
+          </a:effectRef>
+          <a:fontRef idx="minor">
+            <a:schemeClr val="lt1"/>
+          </a:fontRef>
+        </p:style>
+        <p:txBody>
+          <a:bodyPr rtlCol="0" anchor="ctr"/>
+          <a:lstStyle/>
+          <a:p>
+            <a:pPr algn="ctr"/>
+            <a:endParaRPr lang="en-US" dirty="0"/>
+          </a:p>
+        </p:txBody>
+      </p:sp>
+      <p:sp>
+        <p:nvSpPr>
+          <p:cNvPr id="5" name="TextBox 4">
+            <a:extLst>
+              <a:ext uri="{FF2B5EF4-FFF2-40B4-BE49-F238E27FC236}">
+                <a16:creationId xmlns:a16="http://schemas.microsoft.com/office/drawing/2014/main" id="{CCC1E398-E049-CD9D-0784-E168464E0A39}"/>
+              </a:ext>
+            </a:extLst>
+          </p:cNvPr>
+          <p:cNvSpPr txBox="1"/>
+          <p:nvPr/>
+        </p:nvSpPr>
+        <p:spPr>
+          <a:xfrm>
+            <a:off x="462987" y="572220"/>
+            <a:ext cx="11100122" cy="6647974"/>
+          </a:xfrm>
+          <a:prstGeom prst="rect">
+            <a:avLst/>
+          </a:prstGeom>
+          <a:noFill/>
+        </p:spPr>
+        <p:txBody>
+          <a:bodyPr wrap="square" rtlCol="0">
+            <a:spAutoFit/>
+          </a:bodyPr>
+          <a:lstStyle/>
+          <a:p>
+            <a:pPr marL="285750" indent="-285750">
+              <a:buFont typeface="Arial" panose="020B0604020202020204" pitchFamily="34" charset="0"/>
+              <a:buChar char="•"/>
+            </a:pPr>
+            <a:endParaRPr lang="en-US" sz="2400" dirty="0"/>
+          </a:p>
+          <a:p>
+            <a:r>
+              <a:rPr lang="en-US" sz="2400" dirty="0"/>
+              <a:t>Vector Store</a:t>
+            </a:r>
+          </a:p>
+          <a:p>
+            <a:pPr marL="742950" lvl="1" indent="-285750">
+              <a:buFont typeface="Arial" panose="020B0604020202020204" pitchFamily="34" charset="0"/>
+              <a:buChar char="•"/>
+            </a:pPr>
+            <a:r>
+              <a:rPr lang="en-US" sz="2400" dirty="0"/>
               <a:t>Chunking</a:t>
             </a:r>
           </a:p>
@@ -6722,6 +7175,16 @@
             <a:r>
               <a:rPr lang="en-US" sz="2400" dirty="0"/>
               <a:t>Store a summary of the chunked codes and create embeddings based on the summary.  The summary should contain information that you want to know about the chunked codes (ex. The general purpose of the codes, file name, path to the file, functions/pages that use the function being chunked, functions/pages that the function being chunked use, …etc.)</a:t>
+            </a:r>
+          </a:p>
+          <a:p>
+            <a:pPr marL="742950" lvl="1" indent="-285750">
+              <a:buFont typeface="Arial" panose="020B0604020202020204" pitchFamily="34" charset="0"/>
+              <a:buChar char="•"/>
+            </a:pPr>
+            <a:r>
+              <a:rPr lang="en-US" sz="2400" dirty="0"/>
+              <a:t>The detail information is stored as the meta data.</a:t>
             </a:r>
           </a:p>
           <a:p>

</xml_diff>